<commit_message>
presentation: fill in real contact email and GitHub URL
Replaced placeholders across all 5 pitch deck variants (base +
anthropic/aws/microsoft-for-startups/yc): "[ your contact here ]" ->
contact@lakshx.in, github.com/lakshx-ide/lakshx -> github.com/BeastxD7/LakshX-IDE.
Regenerated the .pptx (build_pptx.py) and .pdf (headless print) for each
variant so the binaries match the edited source.

Co-Authored-By: Claude Sonnet 5 <noreply@anthropic.com>
Claude-Session: https://claude.ai/code/session_01Vo1e5qTcNa3JiPpsdjnwfL
</commit_message>
<xml_diff>
--- a/presentation/anthropic/lakshx-pitch-deck.pptx
+++ b/presentation/anthropic/lakshx-pitch-deck.pptx
@@ -6628,7 +6628,7 @@
                 </a:solidFill>
                 <a:latin typeface="Consolas"/>
               </a:rPr>
-              <a:t>github.com/lakshx-ide/lakshx     </a:t>
+              <a:t>github.com/BeastxD7/LakshX-IDE     </a:t>
             </a:r>
             <a:r>
               <a:rPr sz="1000" b="0" i="0">
@@ -6637,7 +6637,7 @@
                 </a:solidFill>
                 <a:latin typeface="Consolas"/>
               </a:rPr>
-              <a:t>[ your contact here ]</a:t>
+              <a:t>contact@lakshx.in</a:t>
             </a:r>
           </a:p>
         </p:txBody>

</xml_diff>